<commit_message>
docs(orgcomp-series): Phase 5.5 seam — one attestation pipeline for every estate (#1290)
Vol VII Book 04 gains 'One Pipeline, Every Estate — the Phase 5 Seam': the
RedHat-on-AWS estate's control state enters the same attestation loop — the
5.1 emission contract feeds the same SI-2 task stream, the 5.2 assessment
feed ranks in the same RA-5 queue, Security Hub/GuardDuty telemetry lands in
the same Evidence Fabric the KSI emit reads — assessed over the whole estate
on the one CM-8 join key, with no per-cloud OSCAL package or second
scorecard. Cross-reference row added to the Vol III Book 03 Phase 5 contract.
Tracked derivatives re-issued at the new Date Code (pptx via aan-deck, docx
patched in place).

This closes the documentation side of workstream 5.5; the remaining epic
criteria are live-estate execution.

Co-Authored-By: Claude Fable 5 <noreply@anthropic.com>
Claude-Session: https://claude.ai/code/session_01N5UTDTQvE1TzezbTuWtxxZ
</commit_message>
<xml_diff>
--- a/docs/customer-documents/orgcomp-series/Vol_VII_Book_04_OrgComp_Control_Attestation_Evidence_KSI.pptx
+++ b/docs/customer-documents/orgcomp-series/Vol_VII_Book_04_OrgComp_Control_Attestation_Evidence_KSI.pptx
@@ -662,7 +662,7 @@
           <a:p/>
           <a:p>
             <a:r>
-              <a:t>Vendor sources: host repo: docs/customer-documents/federal-aan-series/aan-compliance-spine.yml</a:t>
+              <a:t>Vendor sources: host repo: docs/customer-documents/orgcomp-series/orgcomp-compliance-spine.yml</a:t>
             </a:r>
           </a:p>
         </p:txBody>
@@ -1042,7 +1042,7 @@
           <a:p/>
           <a:p>
             <a:r>
-              <a:t>Vendor sources: host repo: docs/customer-documents/federal-aan-series/aan-compliance-spine.yml</a:t>
+              <a:t>Vendor sources: host repo: docs/customer-documents/orgcomp-series/orgcomp-compliance-spine.yml</a:t>
             </a:r>
           </a:p>
         </p:txBody>
@@ -4877,7 +4877,7 @@
                 </a:solidFill>
                 <a:latin typeface="Arial"/>
               </a:rPr>
-              <a:t>Date Code: 2026-07-12 15:00 ET</a:t>
+              <a:t>Date Code: 2026-07-20 01:20 ET</a:t>
             </a:r>
           </a:p>
         </p:txBody>
@@ -5065,7 +5065,7 @@
                 </a:solidFill>
                 <a:latin typeface="Arial"/>
               </a:rPr>
-              <a:t>Control Attestation, Evidence &amp; KSI · Date Code: 2026-07-12 15:00 ET</a:t>
+              <a:t>Control Attestation, Evidence &amp; KSI · Date Code: 2026-07-20 01:20 ET</a:t>
             </a:r>
           </a:p>
         </p:txBody>
@@ -5288,7 +5288,7 @@
                 </a:solidFill>
                 <a:latin typeface="Arial"/>
               </a:rPr>
-              <a:t>Control Attestation, Evidence &amp; KSI · Date Code: 2026-07-12 15:00 ET</a:t>
+              <a:t>Control Attestation, Evidence &amp; KSI · Date Code: 2026-07-20 01:20 ET</a:t>
             </a:r>
           </a:p>
         </p:txBody>
@@ -5494,7 +5494,7 @@
                 </a:solidFill>
                 <a:latin typeface="Arial"/>
               </a:rPr>
-              <a:t>Each control knows which M365/Azure tests attest it — a projection of aan-compliance-spine.yml, not an independent authority.</a:t>
+              <a:t>Each control knows which M365/Azure tests attest it — a projection of orgcomp-compliance-spine.yml, not an independent authority.</a:t>
             </a:r>
           </a:p>
         </p:txBody>
@@ -6195,7 +6195,7 @@
                 </a:solidFill>
                 <a:latin typeface="Arial"/>
               </a:rPr>
-              <a:t>Control Attestation, Evidence &amp; KSI · Date Code: 2026-07-12 15:00 ET</a:t>
+              <a:t>Control Attestation, Evidence &amp; KSI · Date Code: 2026-07-20 01:20 ET</a:t>
             </a:r>
           </a:p>
         </p:txBody>
@@ -7189,7 +7189,7 @@
                 </a:solidFill>
                 <a:latin typeface="Arial"/>
               </a:rPr>
-              <a:t>Control Attestation, Evidence &amp; KSI · Date Code: 2026-07-12 15:00 ET</a:t>
+              <a:t>Control Attestation, Evidence &amp; KSI · Date Code: 2026-07-20 01:20 ET</a:t>
             </a:r>
           </a:p>
         </p:txBody>
@@ -8183,7 +8183,7 @@
                 </a:solidFill>
                 <a:latin typeface="Arial"/>
               </a:rPr>
-              <a:t>Control Attestation, Evidence &amp; KSI · Date Code: 2026-07-12 15:00 ET</a:t>
+              <a:t>Control Attestation, Evidence &amp; KSI · Date Code: 2026-07-20 01:20 ET</a:t>
             </a:r>
           </a:p>
         </p:txBody>
@@ -9177,7 +9177,7 @@
                 </a:solidFill>
                 <a:latin typeface="Arial"/>
               </a:rPr>
-              <a:t>Control Attestation, Evidence &amp; KSI · Date Code: 2026-07-12 15:00 ET</a:t>
+              <a:t>Control Attestation, Evidence &amp; KSI · Date Code: 2026-07-20 01:20 ET</a:t>
             </a:r>
           </a:p>
         </p:txBody>
@@ -10171,7 +10171,7 @@
                 </a:solidFill>
                 <a:latin typeface="Arial"/>
               </a:rPr>
-              <a:t>Control Attestation, Evidence &amp; KSI · Date Code: 2026-07-12 15:00 ET</a:t>
+              <a:t>Control Attestation, Evidence &amp; KSI · Date Code: 2026-07-20 01:20 ET</a:t>
             </a:r>
           </a:p>
         </p:txBody>
@@ -10693,7 +10693,7 @@
                 </a:solidFill>
                 <a:latin typeface="Arial"/>
               </a:rPr>
-              <a:t>Control Attestation, Evidence &amp; KSI · Date Code: 2026-07-12 15:00 ET</a:t>
+              <a:t>Control Attestation, Evidence &amp; KSI · Date Code: 2026-07-20 01:20 ET</a:t>
             </a:r>
           </a:p>
         </p:txBody>

</xml_diff>

<commit_message>
docs(orgcomp-series): Phase 5.5 seam — one attestation pipeline for every estate (#1296)
Vol VII Book 04 gains 'One Pipeline, Every Estate — the Phase 5 Seam': the
RedHat-on-AWS estate's control state enters the same attestation loop — the
5.1 emission contract feeds the same SI-2 task stream, the 5.2 assessment
feed ranks in the same RA-5 queue, Security Hub/GuardDuty telemetry lands in
the same Evidence Fabric the KSI emit reads — assessed over the whole estate
on the one CM-8 join key, with no per-cloud OSCAL package or second
scorecard. Cross-reference row added to the Vol III Book 03 Phase 5 contract.
Tracked derivatives re-issued at the new Date Code (pptx via aan-deck, docx
patched in place).

This closes the documentation side of workstream 5.5; the remaining epic
criteria are live-estate execution.


Claude-Session: https://claude.ai/code/session_01N5UTDTQvE1TzezbTuWtxxZ

Co-authored-by: Claude <noreply@anthropic.com>
</commit_message>
<xml_diff>
--- a/docs/customer-documents/orgcomp-series/Vol_VII_Book_04_OrgComp_Control_Attestation_Evidence_KSI.pptx
+++ b/docs/customer-documents/orgcomp-series/Vol_VII_Book_04_OrgComp_Control_Attestation_Evidence_KSI.pptx
@@ -662,7 +662,7 @@
           <a:p/>
           <a:p>
             <a:r>
-              <a:t>Vendor sources: host repo: docs/customer-documents/federal-aan-series/aan-compliance-spine.yml</a:t>
+              <a:t>Vendor sources: host repo: docs/customer-documents/orgcomp-series/orgcomp-compliance-spine.yml</a:t>
             </a:r>
           </a:p>
         </p:txBody>
@@ -1042,7 +1042,7 @@
           <a:p/>
           <a:p>
             <a:r>
-              <a:t>Vendor sources: host repo: docs/customer-documents/federal-aan-series/aan-compliance-spine.yml</a:t>
+              <a:t>Vendor sources: host repo: docs/customer-documents/orgcomp-series/orgcomp-compliance-spine.yml</a:t>
             </a:r>
           </a:p>
         </p:txBody>
@@ -4877,7 +4877,7 @@
                 </a:solidFill>
                 <a:latin typeface="Arial"/>
               </a:rPr>
-              <a:t>Date Code: 2026-07-12 15:00 ET</a:t>
+              <a:t>Date Code: 2026-07-20 01:20 ET</a:t>
             </a:r>
           </a:p>
         </p:txBody>
@@ -5065,7 +5065,7 @@
                 </a:solidFill>
                 <a:latin typeface="Arial"/>
               </a:rPr>
-              <a:t>Control Attestation, Evidence &amp; KSI · Date Code: 2026-07-12 15:00 ET</a:t>
+              <a:t>Control Attestation, Evidence &amp; KSI · Date Code: 2026-07-20 01:20 ET</a:t>
             </a:r>
           </a:p>
         </p:txBody>
@@ -5288,7 +5288,7 @@
                 </a:solidFill>
                 <a:latin typeface="Arial"/>
               </a:rPr>
-              <a:t>Control Attestation, Evidence &amp; KSI · Date Code: 2026-07-12 15:00 ET</a:t>
+              <a:t>Control Attestation, Evidence &amp; KSI · Date Code: 2026-07-20 01:20 ET</a:t>
             </a:r>
           </a:p>
         </p:txBody>
@@ -5494,7 +5494,7 @@
                 </a:solidFill>
                 <a:latin typeface="Arial"/>
               </a:rPr>
-              <a:t>Each control knows which M365/Azure tests attest it — a projection of aan-compliance-spine.yml, not an independent authority.</a:t>
+              <a:t>Each control knows which M365/Azure tests attest it — a projection of orgcomp-compliance-spine.yml, not an independent authority.</a:t>
             </a:r>
           </a:p>
         </p:txBody>
@@ -6195,7 +6195,7 @@
                 </a:solidFill>
                 <a:latin typeface="Arial"/>
               </a:rPr>
-              <a:t>Control Attestation, Evidence &amp; KSI · Date Code: 2026-07-12 15:00 ET</a:t>
+              <a:t>Control Attestation, Evidence &amp; KSI · Date Code: 2026-07-20 01:20 ET</a:t>
             </a:r>
           </a:p>
         </p:txBody>
@@ -7189,7 +7189,7 @@
                 </a:solidFill>
                 <a:latin typeface="Arial"/>
               </a:rPr>
-              <a:t>Control Attestation, Evidence &amp; KSI · Date Code: 2026-07-12 15:00 ET</a:t>
+              <a:t>Control Attestation, Evidence &amp; KSI · Date Code: 2026-07-20 01:20 ET</a:t>
             </a:r>
           </a:p>
         </p:txBody>
@@ -8183,7 +8183,7 @@
                 </a:solidFill>
                 <a:latin typeface="Arial"/>
               </a:rPr>
-              <a:t>Control Attestation, Evidence &amp; KSI · Date Code: 2026-07-12 15:00 ET</a:t>
+              <a:t>Control Attestation, Evidence &amp; KSI · Date Code: 2026-07-20 01:20 ET</a:t>
             </a:r>
           </a:p>
         </p:txBody>
@@ -9177,7 +9177,7 @@
                 </a:solidFill>
                 <a:latin typeface="Arial"/>
               </a:rPr>
-              <a:t>Control Attestation, Evidence &amp; KSI · Date Code: 2026-07-12 15:00 ET</a:t>
+              <a:t>Control Attestation, Evidence &amp; KSI · Date Code: 2026-07-20 01:20 ET</a:t>
             </a:r>
           </a:p>
         </p:txBody>
@@ -10171,7 +10171,7 @@
                 </a:solidFill>
                 <a:latin typeface="Arial"/>
               </a:rPr>
-              <a:t>Control Attestation, Evidence &amp; KSI · Date Code: 2026-07-12 15:00 ET</a:t>
+              <a:t>Control Attestation, Evidence &amp; KSI · Date Code: 2026-07-20 01:20 ET</a:t>
             </a:r>
           </a:p>
         </p:txBody>
@@ -10693,7 +10693,7 @@
                 </a:solidFill>
                 <a:latin typeface="Arial"/>
               </a:rPr>
-              <a:t>Control Attestation, Evidence &amp; KSI · Date Code: 2026-07-12 15:00 ET</a:t>
+              <a:t>Control Attestation, Evidence &amp; KSI · Date Code: 2026-07-20 01:20 ET</a:t>
             </a:r>
           </a:p>
         </p:txBody>

</xml_diff>